<commit_message>
docs: update slides with the probe and autoscaling fix
</commit_message>
<xml_diff>
--- a/demo/OrderSystem-DevSecOps.pptx
+++ b/demo/OrderSystem-DevSecOps.pptx
@@ -118,41 +118,41 @@
   <p:extLst>
     <p:ext uri="{521415D9-36F7-43E2-AB2F-B90AF26B5E84}">
       <p14:sectionLst xmlns:p14="http://schemas.microsoft.com/office/powerpoint/2010/main">
-        <p14:section name="Introduction" id="{5d96b17c-aecf-32fb-8f52-6bdabea230c8}">
+        <p14:section name="Introduction" id="{fc3efd88-fc2e-9e6b-4f1f-eae96261b7e1}">
           <p14:sldIdLst>
             <p14:sldId id="256"/>
           </p14:sldIdLst>
         </p14:section>
-        <p14:section name="What I Built" id="{de290ca5-d107-182a-a02a-210945cfcd35}">
+        <p14:section name="What I Built" id="{9a2cc149-acda-cfab-9e57-f371d8694872}">
           <p14:sldIdLst>
             <p14:sldId id="257"/>
           </p14:sldIdLst>
         </p14:section>
-        <p14:section name="Architecture" id="{b376fe39-880b-31c6-8360-1af35dca3d04}">
+        <p14:section name="Architecture" id="{001bc0fd-ce8e-1836-8b75-cda7ce6398d4}">
           <p14:sldIdLst>
             <p14:sldId id="258"/>
             <p14:sldId id="259"/>
           </p14:sldIdLst>
         </p14:section>
-        <p14:section name="CI/CD and Security" id="{70e38537-f5a9-bc72-c6bf-48b713861f00}">
+        <p14:section name="CI/CD and Security" id="{8b6e9fef-eba9-e938-3ecf-dc3cc044fd65}">
           <p14:sldIdLst>
             <p14:sldId id="260"/>
             <p14:sldId id="261"/>
           </p14:sldIdLst>
         </p14:section>
-        <p14:section name="Delivery and Platform" id="{5b230b7d-8c8c-870f-ff80-a26fb6f84461}">
+        <p14:section name="Delivery and Platform" id="{96c2e192-06a9-85b4-f88a-dbb90328a7e0}">
           <p14:sldIdLst>
             <p14:sldId id="262"/>
             <p14:sldId id="263"/>
             <p14:sldId id="264"/>
           </p14:sldIdLst>
         </p14:section>
-        <p14:section name="Observability" id="{d9b1b4c9-bc18-3317-9c29-8cacc6c7360e}">
+        <p14:section name="Observability" id="{c81cb1a0-dd70-d5f6-e88d-5fbb800a7f18}">
           <p14:sldIdLst>
             <p14:sldId id="265"/>
           </p14:sldIdLst>
         </p14:section>
-        <p14:section name="Wrap Up" id="{ae2aa1fd-e320-f273-a9ab-9ee170a67f80}">
+        <p14:section name="Wrap Up" id="{bc9d1b8a-b747-e03d-7fa8-d1fcb9eb97bf}">
           <p14:sldIdLst>
             <p14:sldId id="266"/>
             <p14:sldId id="267"/>
@@ -3898,7 +3898,7 @@
                   <a:schemeClr val="tx1"/>
                 </a:solidFill>
               </a:rPr>
-              <a:t>Trivy scan rate limited</a:t>
+              <a:t>Pods stuck in a restart loop</a:t>
             </a:r>
             <a:endParaRPr lang="en-US" sz="1500" dirty="0"/>
           </a:p>
@@ -3951,7 +3951,7 @@
                   <a:schemeClr val="tx2"/>
                 </a:solidFill>
               </a:rPr>
-              <a:t>Maven Central returned HTTP 429</a:t>
+              <a:t>Liveness probe killed the slow JVM boot</a:t>
             </a:r>
             <a:endParaRPr lang="en-US" sz="1300" dirty="0"/>
           </a:p>
@@ -3982,7 +3982,7 @@
                   <a:schemeClr val="tx2"/>
                 </a:solidFill>
               </a:rPr>
-              <a:t>Switched the FS scan to offline mode</a:t>
+              <a:t>Startup probe and a bigger CPU request</a:t>
             </a:r>
             <a:endParaRPr lang="en-US" sz="1300" dirty="0"/>
           </a:p>

</xml_diff>